<commit_message>
chore(slides): update position embeddings
</commit_message>
<xml_diff>
--- a/slides/4-embeddings.pptx
+++ b/slides/4-embeddings.pptx
@@ -693,6 +693,122 @@
     </pc:docChg>
   </pc:docChgLst>
   <pc:docChgLst>
+    <pc:chgData name="Ryan Daniels" userId="S::rkd43@cam.ac.uk::aaa4fbe9-f474-4140-b10b-5257398ac308" providerId="AD" clId="Web-{5FB06A33-2E2E-A888-B9BF-EF47A6C86F6E}"/>
+    <pc:docChg chg="addSld delSld modSld">
+      <pc:chgData name="Ryan Daniels" userId="S::rkd43@cam.ac.uk::aaa4fbe9-f474-4140-b10b-5257398ac308" providerId="AD" clId="Web-{5FB06A33-2E2E-A888-B9BF-EF47A6C86F6E}" dt="2025-09-09T13:36:45.410" v="415"/>
+      <pc:docMkLst>
+        <pc:docMk/>
+      </pc:docMkLst>
+      <pc:sldChg chg="modSp">
+        <pc:chgData name="Ryan Daniels" userId="S::rkd43@cam.ac.uk::aaa4fbe9-f474-4140-b10b-5257398ac308" providerId="AD" clId="Web-{5FB06A33-2E2E-A888-B9BF-EF47A6C86F6E}" dt="2025-09-09T12:07:03.372" v="5" actId="20577"/>
+        <pc:sldMkLst>
+          <pc:docMk/>
+          <pc:sldMk cId="1035996628" sldId="275"/>
+        </pc:sldMkLst>
+        <pc:spChg chg="mod">
+          <ac:chgData name="Ryan Daniels" userId="S::rkd43@cam.ac.uk::aaa4fbe9-f474-4140-b10b-5257398ac308" providerId="AD" clId="Web-{5FB06A33-2E2E-A888-B9BF-EF47A6C86F6E}" dt="2025-09-09T12:07:03.372" v="5" actId="20577"/>
+          <ac:spMkLst>
+            <pc:docMk/>
+            <pc:sldMk cId="1035996628" sldId="275"/>
+            <ac:spMk id="3" creationId="{26BBA0D6-9CEE-5A43-8FE6-1F4021FBCAFD}"/>
+          </ac:spMkLst>
+        </pc:spChg>
+      </pc:sldChg>
+      <pc:sldChg chg="addSp modSp">
+        <pc:chgData name="Ryan Daniels" userId="S::rkd43@cam.ac.uk::aaa4fbe9-f474-4140-b10b-5257398ac308" providerId="AD" clId="Web-{5FB06A33-2E2E-A888-B9BF-EF47A6C86F6E}" dt="2025-09-09T13:36:41.284" v="414" actId="1076"/>
+        <pc:sldMkLst>
+          <pc:docMk/>
+          <pc:sldMk cId="2704578491" sldId="276"/>
+        </pc:sldMkLst>
+      </pc:sldChg>
+      <pc:sldChg chg="delSp del">
+        <pc:chgData name="Ryan Daniels" userId="S::rkd43@cam.ac.uk::aaa4fbe9-f474-4140-b10b-5257398ac308" providerId="AD" clId="Web-{5FB06A33-2E2E-A888-B9BF-EF47A6C86F6E}" dt="2025-09-09T13:36:45.410" v="415"/>
+        <pc:sldMkLst>
+          <pc:docMk/>
+          <pc:sldMk cId="1883872821" sldId="277"/>
+        </pc:sldMkLst>
+      </pc:sldChg>
+      <pc:sldChg chg="addSp delSp modSp new">
+        <pc:chgData name="Ryan Daniels" userId="S::rkd43@cam.ac.uk::aaa4fbe9-f474-4140-b10b-5257398ac308" providerId="AD" clId="Web-{5FB06A33-2E2E-A888-B9BF-EF47A6C86F6E}" dt="2025-09-09T12:14:34.893" v="29" actId="1076"/>
+        <pc:sldMkLst>
+          <pc:docMk/>
+          <pc:sldMk cId="3990571063" sldId="289"/>
+        </pc:sldMkLst>
+        <pc:spChg chg="mod">
+          <ac:chgData name="Ryan Daniels" userId="S::rkd43@cam.ac.uk::aaa4fbe9-f474-4140-b10b-5257398ac308" providerId="AD" clId="Web-{5FB06A33-2E2E-A888-B9BF-EF47A6C86F6E}" dt="2025-09-09T12:13:20.063" v="12" actId="20577"/>
+          <ac:spMkLst>
+            <pc:docMk/>
+            <pc:sldMk cId="3990571063" sldId="289"/>
+            <ac:spMk id="2" creationId="{6DE8872B-321F-9DAD-F0ED-568E1E6FEE20}"/>
+          </ac:spMkLst>
+        </pc:spChg>
+        <pc:spChg chg="add mod">
+          <ac:chgData name="Ryan Daniels" userId="S::rkd43@cam.ac.uk::aaa4fbe9-f474-4140-b10b-5257398ac308" providerId="AD" clId="Web-{5FB06A33-2E2E-A888-B9BF-EF47A6C86F6E}" dt="2025-09-09T12:14:34.893" v="29" actId="1076"/>
+          <ac:spMkLst>
+            <pc:docMk/>
+            <pc:sldMk cId="3990571063" sldId="289"/>
+            <ac:spMk id="6" creationId="{5B6F17E1-285D-FC02-0564-C4D597EFE081}"/>
+          </ac:spMkLst>
+        </pc:spChg>
+        <pc:picChg chg="add mod">
+          <ac:chgData name="Ryan Daniels" userId="S::rkd43@cam.ac.uk::aaa4fbe9-f474-4140-b10b-5257398ac308" providerId="AD" clId="Web-{5FB06A33-2E2E-A888-B9BF-EF47A6C86F6E}" dt="2025-09-09T12:14:19.501" v="21" actId="1076"/>
+          <ac:picMkLst>
+            <pc:docMk/>
+            <pc:sldMk cId="3990571063" sldId="289"/>
+            <ac:picMk id="5" creationId="{C29A7DFC-A7F5-DDF8-3267-659E608CB9EF}"/>
+          </ac:picMkLst>
+        </pc:picChg>
+      </pc:sldChg>
+      <pc:sldChg chg="addSp delSp modSp new">
+        <pc:chgData name="Ryan Daniels" userId="S::rkd43@cam.ac.uk::aaa4fbe9-f474-4140-b10b-5257398ac308" providerId="AD" clId="Web-{5FB06A33-2E2E-A888-B9BF-EF47A6C86F6E}" dt="2025-09-09T12:21:33.355" v="409" actId="1076"/>
+        <pc:sldMkLst>
+          <pc:docMk/>
+          <pc:sldMk cId="3927874872" sldId="290"/>
+        </pc:sldMkLst>
+        <pc:spChg chg="mod">
+          <ac:chgData name="Ryan Daniels" userId="S::rkd43@cam.ac.uk::aaa4fbe9-f474-4140-b10b-5257398ac308" providerId="AD" clId="Web-{5FB06A33-2E2E-A888-B9BF-EF47A6C86F6E}" dt="2025-09-09T12:15:40.646" v="34" actId="20577"/>
+          <ac:spMkLst>
+            <pc:docMk/>
+            <pc:sldMk cId="3927874872" sldId="290"/>
+            <ac:spMk id="2" creationId="{ADB96252-F3CA-60E3-8ABF-99A14B1C17BF}"/>
+          </ac:spMkLst>
+        </pc:spChg>
+        <pc:spChg chg="add mod">
+          <ac:chgData name="Ryan Daniels" userId="S::rkd43@cam.ac.uk::aaa4fbe9-f474-4140-b10b-5257398ac308" providerId="AD" clId="Web-{5FB06A33-2E2E-A888-B9BF-EF47A6C86F6E}" dt="2025-09-09T12:21:24.918" v="404" actId="14100"/>
+          <ac:spMkLst>
+            <pc:docMk/>
+            <pc:sldMk cId="3927874872" sldId="290"/>
+            <ac:spMk id="6" creationId="{DFBC5676-CEF5-25D8-9E2C-A75C6794EE4B}"/>
+          </ac:spMkLst>
+        </pc:spChg>
+        <pc:spChg chg="add mod">
+          <ac:chgData name="Ryan Daniels" userId="S::rkd43@cam.ac.uk::aaa4fbe9-f474-4140-b10b-5257398ac308" providerId="AD" clId="Web-{5FB06A33-2E2E-A888-B9BF-EF47A6C86F6E}" dt="2025-09-09T12:21:33.355" v="409" actId="1076"/>
+          <ac:spMkLst>
+            <pc:docMk/>
+            <pc:sldMk cId="3927874872" sldId="290"/>
+            <ac:spMk id="7" creationId="{6F9DB712-71EB-1064-40C9-4B3477EED38A}"/>
+          </ac:spMkLst>
+        </pc:spChg>
+        <pc:graphicFrameChg chg="add mod modGraphic">
+          <ac:chgData name="Ryan Daniels" userId="S::rkd43@cam.ac.uk::aaa4fbe9-f474-4140-b10b-5257398ac308" providerId="AD" clId="Web-{5FB06A33-2E2E-A888-B9BF-EF47A6C86F6E}" dt="2025-09-09T12:20:32.074" v="379" actId="1076"/>
+          <ac:graphicFrameMkLst>
+            <pc:docMk/>
+            <pc:sldMk cId="3927874872" sldId="290"/>
+            <ac:graphicFrameMk id="4" creationId="{CD91162D-9315-7F7F-17E8-9BD601A493DA}"/>
+          </ac:graphicFrameMkLst>
+        </pc:graphicFrameChg>
+        <pc:graphicFrameChg chg="add mod modGraphic">
+          <ac:chgData name="Ryan Daniels" userId="S::rkd43@cam.ac.uk::aaa4fbe9-f474-4140-b10b-5257398ac308" providerId="AD" clId="Web-{5FB06A33-2E2E-A888-B9BF-EF47A6C86F6E}" dt="2025-09-09T12:20:37.730" v="380" actId="1076"/>
+          <ac:graphicFrameMkLst>
+            <pc:docMk/>
+            <pc:sldMk cId="3927874872" sldId="290"/>
+            <ac:graphicFrameMk id="5" creationId="{16A0A5D4-9CFB-BF19-B7E4-6925ACF1C489}"/>
+          </ac:graphicFrameMkLst>
+        </pc:graphicFrameChg>
+      </pc:sldChg>
+    </pc:docChg>
+  </pc:docChgLst>
+  <pc:docChgLst>
     <pc:chgData name="Ryan Daniels" userId="S::rkd43@cam.ac.uk::aaa4fbe9-f474-4140-b10b-5257398ac308" providerId="AD" clId="Web-{C6910A1E-EBE7-FFC2-D63D-F23023DD8B7A}"/>
     <pc:docChg chg="addSld delSld modSld addMainMaster">
       <pc:chgData name="Ryan Daniels" userId="S::rkd43@cam.ac.uk::aaa4fbe9-f474-4140-b10b-5257398ac308" providerId="AD" clId="Web-{C6910A1E-EBE7-FFC2-D63D-F23023DD8B7A}" dt="2025-09-05T12:54:05.596" v="409"/>
@@ -1378,122 +1494,6 @@
           </pc:sldLayoutMkLst>
         </pc:sldLayoutChg>
       </pc:sldMasterChg>
-    </pc:docChg>
-  </pc:docChgLst>
-  <pc:docChgLst>
-    <pc:chgData name="Ryan Daniels" userId="S::rkd43@cam.ac.uk::aaa4fbe9-f474-4140-b10b-5257398ac308" providerId="AD" clId="Web-{5FB06A33-2E2E-A888-B9BF-EF47A6C86F6E}"/>
-    <pc:docChg chg="addSld delSld modSld">
-      <pc:chgData name="Ryan Daniels" userId="S::rkd43@cam.ac.uk::aaa4fbe9-f474-4140-b10b-5257398ac308" providerId="AD" clId="Web-{5FB06A33-2E2E-A888-B9BF-EF47A6C86F6E}" dt="2025-09-09T13:36:45.410" v="415"/>
-      <pc:docMkLst>
-        <pc:docMk/>
-      </pc:docMkLst>
-      <pc:sldChg chg="modSp">
-        <pc:chgData name="Ryan Daniels" userId="S::rkd43@cam.ac.uk::aaa4fbe9-f474-4140-b10b-5257398ac308" providerId="AD" clId="Web-{5FB06A33-2E2E-A888-B9BF-EF47A6C86F6E}" dt="2025-09-09T12:07:03.372" v="5" actId="20577"/>
-        <pc:sldMkLst>
-          <pc:docMk/>
-          <pc:sldMk cId="1035996628" sldId="275"/>
-        </pc:sldMkLst>
-        <pc:spChg chg="mod">
-          <ac:chgData name="Ryan Daniels" userId="S::rkd43@cam.ac.uk::aaa4fbe9-f474-4140-b10b-5257398ac308" providerId="AD" clId="Web-{5FB06A33-2E2E-A888-B9BF-EF47A6C86F6E}" dt="2025-09-09T12:07:03.372" v="5" actId="20577"/>
-          <ac:spMkLst>
-            <pc:docMk/>
-            <pc:sldMk cId="1035996628" sldId="275"/>
-            <ac:spMk id="3" creationId="{26BBA0D6-9CEE-5A43-8FE6-1F4021FBCAFD}"/>
-          </ac:spMkLst>
-        </pc:spChg>
-      </pc:sldChg>
-      <pc:sldChg chg="addSp modSp">
-        <pc:chgData name="Ryan Daniels" userId="S::rkd43@cam.ac.uk::aaa4fbe9-f474-4140-b10b-5257398ac308" providerId="AD" clId="Web-{5FB06A33-2E2E-A888-B9BF-EF47A6C86F6E}" dt="2025-09-09T13:36:41.284" v="414" actId="1076"/>
-        <pc:sldMkLst>
-          <pc:docMk/>
-          <pc:sldMk cId="2704578491" sldId="276"/>
-        </pc:sldMkLst>
-      </pc:sldChg>
-      <pc:sldChg chg="delSp del">
-        <pc:chgData name="Ryan Daniels" userId="S::rkd43@cam.ac.uk::aaa4fbe9-f474-4140-b10b-5257398ac308" providerId="AD" clId="Web-{5FB06A33-2E2E-A888-B9BF-EF47A6C86F6E}" dt="2025-09-09T13:36:45.410" v="415"/>
-        <pc:sldMkLst>
-          <pc:docMk/>
-          <pc:sldMk cId="1883872821" sldId="277"/>
-        </pc:sldMkLst>
-      </pc:sldChg>
-      <pc:sldChg chg="addSp delSp modSp new">
-        <pc:chgData name="Ryan Daniels" userId="S::rkd43@cam.ac.uk::aaa4fbe9-f474-4140-b10b-5257398ac308" providerId="AD" clId="Web-{5FB06A33-2E2E-A888-B9BF-EF47A6C86F6E}" dt="2025-09-09T12:14:34.893" v="29" actId="1076"/>
-        <pc:sldMkLst>
-          <pc:docMk/>
-          <pc:sldMk cId="3990571063" sldId="289"/>
-        </pc:sldMkLst>
-        <pc:spChg chg="mod">
-          <ac:chgData name="Ryan Daniels" userId="S::rkd43@cam.ac.uk::aaa4fbe9-f474-4140-b10b-5257398ac308" providerId="AD" clId="Web-{5FB06A33-2E2E-A888-B9BF-EF47A6C86F6E}" dt="2025-09-09T12:13:20.063" v="12" actId="20577"/>
-          <ac:spMkLst>
-            <pc:docMk/>
-            <pc:sldMk cId="3990571063" sldId="289"/>
-            <ac:spMk id="2" creationId="{6DE8872B-321F-9DAD-F0ED-568E1E6FEE20}"/>
-          </ac:spMkLst>
-        </pc:spChg>
-        <pc:spChg chg="add mod">
-          <ac:chgData name="Ryan Daniels" userId="S::rkd43@cam.ac.uk::aaa4fbe9-f474-4140-b10b-5257398ac308" providerId="AD" clId="Web-{5FB06A33-2E2E-A888-B9BF-EF47A6C86F6E}" dt="2025-09-09T12:14:34.893" v="29" actId="1076"/>
-          <ac:spMkLst>
-            <pc:docMk/>
-            <pc:sldMk cId="3990571063" sldId="289"/>
-            <ac:spMk id="6" creationId="{5B6F17E1-285D-FC02-0564-C4D597EFE081}"/>
-          </ac:spMkLst>
-        </pc:spChg>
-        <pc:picChg chg="add mod">
-          <ac:chgData name="Ryan Daniels" userId="S::rkd43@cam.ac.uk::aaa4fbe9-f474-4140-b10b-5257398ac308" providerId="AD" clId="Web-{5FB06A33-2E2E-A888-B9BF-EF47A6C86F6E}" dt="2025-09-09T12:14:19.501" v="21" actId="1076"/>
-          <ac:picMkLst>
-            <pc:docMk/>
-            <pc:sldMk cId="3990571063" sldId="289"/>
-            <ac:picMk id="5" creationId="{C29A7DFC-A7F5-DDF8-3267-659E608CB9EF}"/>
-          </ac:picMkLst>
-        </pc:picChg>
-      </pc:sldChg>
-      <pc:sldChg chg="addSp delSp modSp new">
-        <pc:chgData name="Ryan Daniels" userId="S::rkd43@cam.ac.uk::aaa4fbe9-f474-4140-b10b-5257398ac308" providerId="AD" clId="Web-{5FB06A33-2E2E-A888-B9BF-EF47A6C86F6E}" dt="2025-09-09T12:21:33.355" v="409" actId="1076"/>
-        <pc:sldMkLst>
-          <pc:docMk/>
-          <pc:sldMk cId="3927874872" sldId="290"/>
-        </pc:sldMkLst>
-        <pc:spChg chg="mod">
-          <ac:chgData name="Ryan Daniels" userId="S::rkd43@cam.ac.uk::aaa4fbe9-f474-4140-b10b-5257398ac308" providerId="AD" clId="Web-{5FB06A33-2E2E-A888-B9BF-EF47A6C86F6E}" dt="2025-09-09T12:15:40.646" v="34" actId="20577"/>
-          <ac:spMkLst>
-            <pc:docMk/>
-            <pc:sldMk cId="3927874872" sldId="290"/>
-            <ac:spMk id="2" creationId="{ADB96252-F3CA-60E3-8ABF-99A14B1C17BF}"/>
-          </ac:spMkLst>
-        </pc:spChg>
-        <pc:spChg chg="add mod">
-          <ac:chgData name="Ryan Daniels" userId="S::rkd43@cam.ac.uk::aaa4fbe9-f474-4140-b10b-5257398ac308" providerId="AD" clId="Web-{5FB06A33-2E2E-A888-B9BF-EF47A6C86F6E}" dt="2025-09-09T12:21:24.918" v="404" actId="14100"/>
-          <ac:spMkLst>
-            <pc:docMk/>
-            <pc:sldMk cId="3927874872" sldId="290"/>
-            <ac:spMk id="6" creationId="{DFBC5676-CEF5-25D8-9E2C-A75C6794EE4B}"/>
-          </ac:spMkLst>
-        </pc:spChg>
-        <pc:spChg chg="add mod">
-          <ac:chgData name="Ryan Daniels" userId="S::rkd43@cam.ac.uk::aaa4fbe9-f474-4140-b10b-5257398ac308" providerId="AD" clId="Web-{5FB06A33-2E2E-A888-B9BF-EF47A6C86F6E}" dt="2025-09-09T12:21:33.355" v="409" actId="1076"/>
-          <ac:spMkLst>
-            <pc:docMk/>
-            <pc:sldMk cId="3927874872" sldId="290"/>
-            <ac:spMk id="7" creationId="{6F9DB712-71EB-1064-40C9-4B3477EED38A}"/>
-          </ac:spMkLst>
-        </pc:spChg>
-        <pc:graphicFrameChg chg="add mod modGraphic">
-          <ac:chgData name="Ryan Daniels" userId="S::rkd43@cam.ac.uk::aaa4fbe9-f474-4140-b10b-5257398ac308" providerId="AD" clId="Web-{5FB06A33-2E2E-A888-B9BF-EF47A6C86F6E}" dt="2025-09-09T12:20:32.074" v="379" actId="1076"/>
-          <ac:graphicFrameMkLst>
-            <pc:docMk/>
-            <pc:sldMk cId="3927874872" sldId="290"/>
-            <ac:graphicFrameMk id="4" creationId="{CD91162D-9315-7F7F-17E8-9BD601A493DA}"/>
-          </ac:graphicFrameMkLst>
-        </pc:graphicFrameChg>
-        <pc:graphicFrameChg chg="add mod modGraphic">
-          <ac:chgData name="Ryan Daniels" userId="S::rkd43@cam.ac.uk::aaa4fbe9-f474-4140-b10b-5257398ac308" providerId="AD" clId="Web-{5FB06A33-2E2E-A888-B9BF-EF47A6C86F6E}" dt="2025-09-09T12:20:37.730" v="380" actId="1076"/>
-          <ac:graphicFrameMkLst>
-            <pc:docMk/>
-            <pc:sldMk cId="3927874872" sldId="290"/>
-            <ac:graphicFrameMk id="5" creationId="{16A0A5D4-9CFB-BF19-B7E4-6925ACF1C489}"/>
-          </ac:graphicFrameMkLst>
-        </pc:graphicFrameChg>
-      </pc:sldChg>
     </pc:docChg>
   </pc:docChgLst>
   <pc:docChgLst>

</xml_diff>